<commit_message>
docs(governance): Präsentation konsistent auf drei Konzern-Verbindungen
Folie 10 und 11 nannten noch "zwei Verbindungen" und widersprachen den
korrigierten Folien 4/6. Kennzahl "2.821 Zeilen" auf "rund 2.800" entschärft
(review-fest gegen kleine Drift).
</commit_message>
<xml_diff>
--- a/docs/governance/Stoerungsinfos-BlueZone.pptx
+++ b/docs/governance/Stoerungsinfos-BlueZone.pptx
@@ -3839,7 +3839,7 @@
         <p:spPr>
           <a:xfrm>
             <a:off x="777240" y="1874519"/>
-            <a:ext cx="5257800" cy="2587752"/>
+            <a:ext cx="5257800" cy="2811780"/>
           </a:xfrm>
           <a:prstGeom prst="rect">
             <a:avLst/>
@@ -3885,7 +3885,7 @@
         <p:spPr>
           <a:xfrm>
             <a:off x="777240" y="1874519"/>
-            <a:ext cx="73152" cy="2587752"/>
+            <a:ext cx="73152" cy="2811780"/>
           </a:xfrm>
           <a:prstGeom prst="rect">
             <a:avLst/>
@@ -4014,7 +4014,7 @@
                 </a:solidFill>
                 <a:latin typeface="Calibri"/>
               </a:rPr>
-              <a:t>Firewall: wie beantrage ich die 2 ausgehenden Verbindungen?</a:t>
+              <a:t>Firewall: wie beantrage ich die 3 ausgehenden Verbindungen (DB, IdP, Relay)?</a:t>
             </a:r>
           </a:p>
         </p:txBody>
@@ -4027,7 +4027,7 @@
         </p:nvSpPr>
         <p:spPr>
           <a:xfrm>
-            <a:off x="1005840" y="2766060"/>
+            <a:off x="1005840" y="2990088"/>
             <a:ext cx="4800600" cy="548640"/>
           </a:xfrm>
           <a:prstGeom prst="rect">
@@ -4081,7 +4081,7 @@
         </p:nvSpPr>
         <p:spPr>
           <a:xfrm>
-            <a:off x="1005840" y="3145536"/>
+            <a:off x="1005840" y="3369564"/>
             <a:ext cx="4800600" cy="548640"/>
           </a:xfrm>
           <a:prstGeom prst="rect">
@@ -4135,7 +4135,7 @@
         </p:nvSpPr>
         <p:spPr>
           <a:xfrm>
-            <a:off x="1005840" y="3749039"/>
+            <a:off x="1005840" y="3973068"/>
             <a:ext cx="4800600" cy="548640"/>
           </a:xfrm>
           <a:prstGeom prst="rect">
@@ -5135,7 +5135,7 @@
                 </a:solidFill>
                 <a:latin typeface="Calibri"/>
               </a:rPr>
-              <a:t>Zwei ausgehende Verbindungen, keine Zusatz-Infrastruktur, kein Tracking.</a:t>
+              <a:t>Drei Konzern-Verbindungen (DB, IdP, Relay), keine Zusatz-Infrastruktur, kein Tracking.</a:t>
             </a:r>
           </a:p>
         </p:txBody>
@@ -10785,7 +10785,7 @@
                 </a:solidFill>
                 <a:latin typeface="Calibri"/>
               </a:rPr>
-              <a:t>2.821 Zeilen Anwendungscode · 39 Module · 158 automatische Tests · 3 Konzern-Verbindungen · kein Broker, kein Cache, kein Zweitspeicher</a:t>
+              <a:t>rund 2.800 Zeilen Anwendungscode · 39 Module · 158 automatische Tests · 3 Konzern-Verbindungen · kein Broker, kein Cache, kein Zweitspeicher</a:t>
             </a:r>
           </a:p>
         </p:txBody>

</xml_diff>

<commit_message>
docs: README-Überblick, RUNBOOK, CHANGELOG und Fragenregister nachgezogen
- README: Abschnitt „Prozesse: wie man sie anstößt und wo das Ergebnis
  liegt“ (Prüfen und Testen, Lieferkette und Compliance, Entwickeln und
  Betreiben) und „Wo steht was“.
- RUNBOOK: Major-Upgrade von PostgreSQL mit Umzugsskript und Rückweg,
  Backup über die Sicherung der VM, Tageslimit für den Testversand,
  Lockfile, Stücklisten und Schwachstellenbericht (5b).
- ARCHITECTURE: Verbindungen des Entwicklerrechners für `make governance`.
- open-questions: zwei Fremdschnittstellen (AD, Mailserver), Sicherung über
  Tivoli Storage Manager, Stand des Schwachstellenscans (B10), Vorgaben für
  Stückliste und Bericht (B12).
- CHANGELOG (Unreleased) und Gesprächsfolien auf dem Stand der Änderungen.
</commit_message>
<xml_diff>
--- a/docs/governance/Stoerungsinfos-BlueZone.pptx
+++ b/docs/governance/Stoerungsinfos-BlueZone.pptx
@@ -4014,7 +4014,7 @@
                 </a:solidFill>
                 <a:latin typeface="Calibri"/>
               </a:rPr>
-              <a:t>Firewall: wie beantrage ich die 3 ausgehenden Verbindungen (DB, IdP, Relay)?</a:t>
+              <a:t>Firewall: wie beantrage ich die 2 ausgehenden Verbindungen (IdP, Relay)?</a:t>
             </a:r>
           </a:p>
         </p:txBody>
@@ -4068,7 +4068,7 @@
                 </a:solidFill>
                 <a:latin typeface="Calibri"/>
               </a:rPr>
-              <a:t>DB: Schemarechte? TLS-Pflicht? Sicherung/Wiederherstellung?</a:t>
+              <a:t>Eigene DB: Die VM sichert TSM — gelten weitere Vorgaben?</a:t>
             </a:r>
           </a:p>
         </p:txBody>
@@ -5135,7 +5135,7 @@
                 </a:solidFill>
                 <a:latin typeface="Calibri"/>
               </a:rPr>
-              <a:t>Drei Konzern-Verbindungen (DB, IdP, Relay), keine Zusatz-Infrastruktur, kein Tracking.</a:t>
+              <a:t>Zwei Konzern-Verbindungen (IdP, Relay), keine Zusatz-Infrastruktur, kein Tracking.</a:t>
             </a:r>
           </a:p>
         </p:txBody>
@@ -5665,7 +5665,7 @@
         <p:spPr>
           <a:xfrm>
             <a:off x="777240" y="1965960"/>
-            <a:ext cx="10607040" cy="1051560"/>
+            <a:ext cx="10607040" cy="1280160"/>
           </a:xfrm>
           <a:prstGeom prst="rect">
             <a:avLst/>
@@ -5709,7 +5709,7 @@
         <p:spPr>
           <a:xfrm>
             <a:off x="777240" y="1965960"/>
-            <a:ext cx="82296" cy="1051560"/>
+            <a:ext cx="82296" cy="1280160"/>
           </a:xfrm>
           <a:prstGeom prst="rect">
             <a:avLst/>
@@ -7903,7 +7903,7 @@
                 </a:solidFill>
                 <a:latin typeface="Calibri"/>
               </a:rPr>
-              <a:t>Statische HTML-Seiten · Python/FastAPI · MariaDB · Keycloak · NGINX — alles in Containern</a:t>
+              <a:t>Statische HTML-Seiten · Python/FastAPI · PostgreSQL · Keycloak · NGINX — alles in Containern</a:t>
             </a:r>
           </a:p>
         </p:txBody>
@@ -8151,7 +8151,7 @@
             <a:avLst/>
           </a:prstGeom>
           <a:solidFill>
-            <a:srgbClr val="F9F2E4"/>
+            <a:srgbClr val="E9F0F6"/>
           </a:solidFill>
           <a:ln w="15875">
             <a:solidFill>
@@ -8182,7 +8182,7 @@
             <a:r>
               <a:rPr sz="1300" b="1">
                 <a:solidFill>
-                  <a:srgbClr val="8A5713"/>
+                  <a:srgbClr val="1F4D78"/>
                 </a:solidFill>
                 <a:latin typeface="Calibri"/>
               </a:rPr>
@@ -8194,11 +8194,11 @@
             <a:r>
               <a:rPr sz="1000">
                 <a:solidFill>
-                  <a:srgbClr val="8A5713"/>
-                </a:solidFill>
-                <a:latin typeface="Calibri"/>
-              </a:rPr>
-              <a:t>Konzern</a:t>
+                  <a:srgbClr val="1F4D78"/>
+                </a:solidFill>
+                <a:latin typeface="Calibri"/>
+              </a:rPr>
+              <a:t>Container</a:t>
             </a:r>
           </a:p>
         </p:txBody>
@@ -8664,8 +8664,8 @@
         </p:nvSpPr>
         <p:spPr>
           <a:xfrm>
-            <a:off x="1828800" y="1892808"/>
-            <a:ext cx="2670048" cy="292608"/>
+            <a:off x="4038600" y="2438400"/>
+            <a:ext cx="1905000" cy="292608"/>
           </a:xfrm>
           <a:prstGeom prst="rect">
             <a:avLst/>
@@ -8829,7 +8829,7 @@
                 </a:solidFill>
                 <a:latin typeface="Calibri"/>
               </a:rPr>
-              <a:t>Drei Verbindungen zu Konzern-Systemen — Datenbank, Identity Provider, Mailrelay — alle im Intranet. </a:t>
+              <a:t>Zwei Verbindungen zu Konzern-Systemen — Identity Provider, Mailrelay — beide im Intranet. </a:t>
             </a:r>
             <a:r>
               <a:rPr sz="1400" b="0">
@@ -8838,7 +8838,7 @@
                 </a:solidFill>
                 <a:latin typeface="Calibri"/>
               </a:rPr>
-              <a:t>Keine Fremd-APIs, kein Internet. (Die öffentliche Demo nutzt bewusst Gmail-Relay, Let’s Encrypt und Cloudflare — im Zielbild entfällt das.)</a:t>
+              <a:t>Die Datenbank läuft als Container auf derselben Maschine. Keine Fremd-APIs, kein Internet. (Die öffentliche Demo nutzt bewusst Gmail-Relay, Let’s Encrypt und Cloudflare — im Zielbild entfällt das.)</a:t>
             </a:r>
           </a:p>
         </p:txBody>
@@ -9863,7 +9863,7 @@
                 </a:solidFill>
                 <a:latin typeface="Calibri"/>
               </a:rPr>
-              <a:t>Versionierte Migrationen, ausschließlich additiv — kein Schritt verliert Daten.</a:t>
+              <a:t>Versionierte Migrationen, ausschließlich additiv — nichts am Schema fällt weg.</a:t>
             </a:r>
           </a:p>
         </p:txBody>
@@ -10574,7 +10574,7 @@
                 </a:solidFill>
                 <a:latin typeface="Calibri"/>
               </a:rPr>
-              <a:t>Verarbeitet werden Mailadresse und Abos. Sonst keine Personendaten.</a:t>
+              <a:t>Verarbeitet werden Mailadresse, SSO-Kennung, Abos, Kontostatus, Zeitpunkt von Kontoanlage und letzter Anmeldung, Versandprotokoll je Adresse und Protokoll der Admin-Aktionen. Der Webserver protokolliert IP-Adressen. Keine Namen.</a:t>
             </a:r>
           </a:p>
         </p:txBody>
@@ -10785,7 +10785,7 @@
                 </a:solidFill>
                 <a:latin typeface="Calibri"/>
               </a:rPr>
-              <a:t>rund 2.800 Zeilen Anwendungscode · 39 Module · 158 automatische Tests · 3 Konzern-Verbindungen · kein Broker, kein Cache, kein Zweitspeicher</a:t>
+              <a:t>rund 3.000 Zeilen Anwendungscode · rund 40 Module · über 1.000 automatische Tests · 2 Konzern-Verbindungen · kein Broker, kein Cache, kein Zweitspeicher</a:t>
             </a:r>
           </a:p>
         </p:txBody>
@@ -12304,7 +12304,7 @@
                 </a:solidFill>
                 <a:latin typeface="Calibri"/>
               </a:rPr>
-              <a:t>verschlüsselte Datenbankverbindung · Rechte des DB-Kontos für Schemaänderungen · wo die Verschlüsselung endet · Zusicherung, dass der Versandteil auf genau einer Instanz läuft (mehrere würden doppelt versenden). Diese vier sind uns bekannt.</a:t>
+              <a:t>wo die Verschlüsselung endet · Zusicherung, dass der Versandteil auf genau einer Instanz läuft (mehrere würden doppelt versenden). Diese beiden sind uns bekannt.</a:t>
             </a:r>
           </a:p>
         </p:txBody>
@@ -12832,7 +12832,7 @@
                 </a:solidFill>
                 <a:latin typeface="Calibri"/>
               </a:rPr>
-              <a:t>Test-/Integrationsstufen von IdP, DB, ADS, Relay — oder nur produktiv?</a:t>
+              <a:t>Test-/Integrationsstufen von IdP, ADS, Relay — oder nur produktiv?</a:t>
             </a:r>
           </a:p>
         </p:txBody>

</xml_diff>